<commit_message>
work done at home
</commit_message>
<xml_diff>
--- a/slides for class/my slides/About JavaScript - new template.pptx
+++ b/slides for class/my slides/About JavaScript - new template.pptx
@@ -27,6 +27,12 @@
     <p:sldId id="275" r:id="rId21"/>
     <p:sldId id="276" r:id="rId22"/>
     <p:sldId id="277" r:id="rId23"/>
+    <p:sldId id="278" r:id="rId24"/>
+    <p:sldId id="279" r:id="rId25"/>
+    <p:sldId id="280" r:id="rId26"/>
+    <p:sldId id="281" r:id="rId27"/>
+    <p:sldId id="282" r:id="rId28"/>
+    <p:sldId id="283" r:id="rId29"/>
   </p:sldIdLst>
   <p:sldSz cx="12192000" cy="6858000"/>
   <p:notesSz cx="6858000" cy="9144000"/>
@@ -314,7 +320,7 @@
           <a:p>
             <a:fld id="{48A87A34-81AB-432B-8DAE-1953F412C126}" type="datetimeFigureOut">
               <a:rPr lang="en-US" dirty="0"/>
-              <a:t>7/13/25</a:t>
+              <a:t>8/7/25</a:t>
             </a:fld>
             <a:endParaRPr lang="en-US" dirty="0"/>
           </a:p>
@@ -576,7 +582,7 @@
           <a:p>
             <a:fld id="{48A87A34-81AB-432B-8DAE-1953F412C126}" type="datetimeFigureOut">
               <a:rPr lang="en-US" dirty="0"/>
-              <a:t>7/13/25</a:t>
+              <a:t>8/7/25</a:t>
             </a:fld>
             <a:endParaRPr lang="en-US" dirty="0"/>
           </a:p>
@@ -803,7 +809,7 @@
             <a:fld id="{48A87A34-81AB-432B-8DAE-1953F412C126}" type="datetimeFigureOut">
               <a:rPr lang="en-US" dirty="0"/>
               <a:pPr/>
-              <a:t>7/13/25</a:t>
+              <a:t>8/7/25</a:t>
             </a:fld>
             <a:endParaRPr lang="en-US" dirty="0"/>
           </a:p>
@@ -1109,7 +1115,7 @@
             <a:fld id="{48A87A34-81AB-432B-8DAE-1953F412C126}" type="datetimeFigureOut">
               <a:rPr lang="en-US" dirty="0"/>
               <a:pPr/>
-              <a:t>7/13/25</a:t>
+              <a:t>8/7/25</a:t>
             </a:fld>
             <a:endParaRPr lang="en-US" dirty="0"/>
           </a:p>
@@ -1578,7 +1584,7 @@
             <a:fld id="{48A87A34-81AB-432B-8DAE-1953F412C126}" type="datetimeFigureOut">
               <a:rPr lang="en-US" dirty="0"/>
               <a:pPr/>
-              <a:t>7/13/25</a:t>
+              <a:t>8/7/25</a:t>
             </a:fld>
             <a:endParaRPr lang="en-US" dirty="0"/>
           </a:p>
@@ -2120,7 +2126,7 @@
           <a:p>
             <a:fld id="{48A87A34-81AB-432B-8DAE-1953F412C126}" type="datetimeFigureOut">
               <a:rPr lang="en-US" dirty="0"/>
-              <a:t>7/13/25</a:t>
+              <a:t>8/7/25</a:t>
             </a:fld>
             <a:endParaRPr lang="en-US" dirty="0"/>
           </a:p>
@@ -2889,7 +2895,7 @@
           <a:p>
             <a:fld id="{48A87A34-81AB-432B-8DAE-1953F412C126}" type="datetimeFigureOut">
               <a:rPr lang="en-US" dirty="0"/>
-              <a:t>7/13/25</a:t>
+              <a:t>8/7/25</a:t>
             </a:fld>
             <a:endParaRPr lang="en-US" dirty="0"/>
           </a:p>
@@ -3059,7 +3065,7 @@
           <a:p>
             <a:fld id="{48A87A34-81AB-432B-8DAE-1953F412C126}" type="datetimeFigureOut">
               <a:rPr lang="en-US" dirty="0"/>
-              <a:t>7/13/25</a:t>
+              <a:t>8/7/25</a:t>
             </a:fld>
             <a:endParaRPr lang="en-US" dirty="0"/>
           </a:p>
@@ -3278,7 +3284,7 @@
             <a:fld id="{48A87A34-81AB-432B-8DAE-1953F412C126}" type="datetimeFigureOut">
               <a:rPr lang="en-US" dirty="0"/>
               <a:pPr/>
-              <a:t>7/13/25</a:t>
+              <a:t>8/7/25</a:t>
             </a:fld>
             <a:endParaRPr lang="en-US" dirty="0"/>
           </a:p>
@@ -3453,7 +3459,7 @@
           <a:p>
             <a:fld id="{48A87A34-81AB-432B-8DAE-1953F412C126}" type="datetimeFigureOut">
               <a:rPr lang="en-US" dirty="0"/>
-              <a:t>7/13/25</a:t>
+              <a:t>8/7/25</a:t>
             </a:fld>
             <a:endParaRPr lang="en-US" dirty="0"/>
           </a:p>
@@ -3738,7 +3744,7 @@
             <a:fld id="{48A87A34-81AB-432B-8DAE-1953F412C126}" type="datetimeFigureOut">
               <a:rPr lang="en-US" dirty="0"/>
               <a:pPr/>
-              <a:t>7/13/25</a:t>
+              <a:t>8/7/25</a:t>
             </a:fld>
             <a:endParaRPr lang="en-US" dirty="0"/>
           </a:p>
@@ -3975,7 +3981,7 @@
           <a:p>
             <a:fld id="{48A87A34-81AB-432B-8DAE-1953F412C126}" type="datetimeFigureOut">
               <a:rPr lang="en-US" dirty="0"/>
-              <a:t>7/13/25</a:t>
+              <a:t>8/7/25</a:t>
             </a:fld>
             <a:endParaRPr lang="en-US" dirty="0"/>
           </a:p>
@@ -4349,7 +4355,7 @@
           <a:p>
             <a:fld id="{48A87A34-81AB-432B-8DAE-1953F412C126}" type="datetimeFigureOut">
               <a:rPr lang="en-US" dirty="0"/>
-              <a:t>7/13/25</a:t>
+              <a:t>8/7/25</a:t>
             </a:fld>
             <a:endParaRPr lang="en-US" dirty="0"/>
           </a:p>
@@ -4462,7 +4468,7 @@
           <a:p>
             <a:fld id="{48A87A34-81AB-432B-8DAE-1953F412C126}" type="datetimeFigureOut">
               <a:rPr lang="en-US" dirty="0"/>
-              <a:t>7/13/25</a:t>
+              <a:t>8/7/25</a:t>
             </a:fld>
             <a:endParaRPr lang="en-US" dirty="0"/>
           </a:p>
@@ -4552,7 +4558,7 @@
           <a:p>
             <a:fld id="{48A87A34-81AB-432B-8DAE-1953F412C126}" type="datetimeFigureOut">
               <a:rPr lang="en-US" dirty="0"/>
-              <a:t>7/13/25</a:t>
+              <a:t>8/7/25</a:t>
             </a:fld>
             <a:endParaRPr lang="en-US" dirty="0"/>
           </a:p>
@@ -4796,7 +4802,7 @@
           <a:p>
             <a:fld id="{48A87A34-81AB-432B-8DAE-1953F412C126}" type="datetimeFigureOut">
               <a:rPr lang="en-US" dirty="0"/>
-              <a:t>7/13/25</a:t>
+              <a:t>8/7/25</a:t>
             </a:fld>
             <a:endParaRPr lang="en-US" dirty="0"/>
           </a:p>
@@ -5048,7 +5054,7 @@
           <a:p>
             <a:fld id="{48A87A34-81AB-432B-8DAE-1953F412C126}" type="datetimeFigureOut">
               <a:rPr lang="en-US" dirty="0"/>
-              <a:t>7/13/25</a:t>
+              <a:t>8/7/25</a:t>
             </a:fld>
             <a:endParaRPr lang="en-US" dirty="0"/>
           </a:p>
@@ -5287,7 +5293,7 @@
             <a:fld id="{48A87A34-81AB-432B-8DAE-1953F412C126}" type="datetimeFigureOut">
               <a:rPr lang="en-US" dirty="0"/>
               <a:pPr/>
-              <a:t>7/13/25</a:t>
+              <a:t>8/7/25</a:t>
             </a:fld>
             <a:endParaRPr lang="en-US" dirty="0"/>
           </a:p>
@@ -7215,7 +7221,7 @@
         <p:spPr/>
         <p:txBody>
           <a:bodyPr>
-            <a:normAutofit/>
+            <a:normAutofit lnSpcReduction="10000"/>
           </a:bodyPr>
           <a:lstStyle/>
           <a:p>
@@ -7226,7 +7232,7 @@
             </a:pPr>
             <a:r>
               <a:rPr lang="en-US" dirty="0"/>
-              <a:t>JavaScript is a scripting or programming language that allows one to implement complex features on web pages</a:t>
+              <a:t>JavaScript is a scripting or programming language that allows for interactive web pages by enabling dynamic content such as:</a:t>
             </a:r>
           </a:p>
           <a:p>
@@ -7237,7 +7243,7 @@
             </a:pPr>
             <a:r>
               <a:rPr lang="en-US" dirty="0"/>
-              <a:t>Displaying timely content updates</a:t>
+              <a:t>Real-time content updates</a:t>
             </a:r>
           </a:p>
           <a:p>
@@ -7249,6 +7255,17 @@
             <a:r>
               <a:rPr lang="en-US" dirty="0"/>
               <a:t>Interactive maps</a:t>
+            </a:r>
+          </a:p>
+          <a:p>
+            <a:pPr lvl="1">
+              <a:lnSpc>
+                <a:spcPct val="150000"/>
+              </a:lnSpc>
+            </a:pPr>
+            <a:r>
+              <a:rPr lang="en-US" dirty="0"/>
+              <a:t>Form validation</a:t>
             </a:r>
           </a:p>
           <a:p>
@@ -7688,6 +7705,118 @@
             </a:r>
           </a:p>
           <a:p>
+            <a:pPr lvl="1">
+              <a:lnSpc>
+                <a:spcPct val="150000"/>
+              </a:lnSpc>
+            </a:pPr>
+            <a:r>
+              <a:rPr lang="en-US" dirty="0">
+                <a:cs typeface="Courier New" panose="02070309020205020404" pitchFamily="49" charset="0"/>
+              </a:rPr>
+              <a:t>Causes a box to pop up on the screen with whatever message is put in the parentheses</a:t>
+            </a:r>
+            <a:br>
+              <a:rPr lang="en-US" b="1" dirty="0">
+                <a:latin typeface="Courier New" panose="02070309020205020404" pitchFamily="49" charset="0"/>
+                <a:cs typeface="Courier New" panose="02070309020205020404" pitchFamily="49" charset="0"/>
+              </a:rPr>
+            </a:br>
+            <a:r>
+              <a:rPr lang="en-US" b="1" dirty="0">
+                <a:latin typeface="Courier New" panose="02070309020205020404" pitchFamily="49" charset="0"/>
+                <a:cs typeface="Courier New" panose="02070309020205020404" pitchFamily="49" charset="0"/>
+              </a:rPr>
+              <a:t>alert(“Hi there!”);</a:t>
+            </a:r>
+          </a:p>
+        </p:txBody>
+      </p:sp>
+    </p:spTree>
+    <p:extLst>
+      <p:ext uri="{BB962C8B-B14F-4D97-AF65-F5344CB8AC3E}">
+        <p14:creationId xmlns:p14="http://schemas.microsoft.com/office/powerpoint/2010/main" val="1358443088"/>
+      </p:ext>
+    </p:extLst>
+  </p:cSld>
+  <p:clrMapOvr>
+    <a:masterClrMapping/>
+  </p:clrMapOvr>
+</p:sld>
+</file>
+
+<file path=ppt/slides/slide23.xml><?xml version="1.0" encoding="utf-8"?>
+<p:sld xmlns:a="http://schemas.openxmlformats.org/drawingml/2006/main" xmlns:r="http://schemas.openxmlformats.org/officeDocument/2006/relationships" xmlns:p="http://schemas.openxmlformats.org/presentationml/2006/main">
+  <p:cSld>
+    <p:spTree>
+      <p:nvGrpSpPr>
+        <p:cNvPr id="1" name="">
+          <a:extLst>
+            <a:ext uri="{FF2B5EF4-FFF2-40B4-BE49-F238E27FC236}">
+              <a16:creationId xmlns:a16="http://schemas.microsoft.com/office/drawing/2014/main" id="{E678A028-5508-DA0B-6EE0-A48ECF03480F}"/>
+            </a:ext>
+          </a:extLst>
+        </p:cNvPr>
+        <p:cNvGrpSpPr/>
+        <p:nvPr/>
+      </p:nvGrpSpPr>
+      <p:grpSpPr>
+        <a:xfrm>
+          <a:off x="0" y="0"/>
+          <a:ext cx="0" cy="0"/>
+          <a:chOff x="0" y="0"/>
+          <a:chExt cx="0" cy="0"/>
+        </a:xfrm>
+      </p:grpSpPr>
+      <p:sp>
+        <p:nvSpPr>
+          <p:cNvPr id="2" name="Title 1">
+            <a:extLst>
+              <a:ext uri="{FF2B5EF4-FFF2-40B4-BE49-F238E27FC236}">
+                <a16:creationId xmlns:a16="http://schemas.microsoft.com/office/drawing/2014/main" id="{FBE4B8E5-E763-7658-0007-A63190839D5A}"/>
+              </a:ext>
+            </a:extLst>
+          </p:cNvPr>
+          <p:cNvSpPr>
+            <a:spLocks noGrp="1"/>
+          </p:cNvSpPr>
+          <p:nvPr>
+            <p:ph type="title"/>
+          </p:nvPr>
+        </p:nvSpPr>
+        <p:spPr/>
+        <p:txBody>
+          <a:bodyPr/>
+          <a:lstStyle/>
+          <a:p>
+            <a:r>
+              <a:rPr lang="en-US" dirty="0"/>
+              <a:t>Useful JavaScript Methods</a:t>
+            </a:r>
+          </a:p>
+        </p:txBody>
+      </p:sp>
+      <p:sp>
+        <p:nvSpPr>
+          <p:cNvPr id="3" name="Content Placeholder 2">
+            <a:extLst>
+              <a:ext uri="{FF2B5EF4-FFF2-40B4-BE49-F238E27FC236}">
+                <a16:creationId xmlns:a16="http://schemas.microsoft.com/office/drawing/2014/main" id="{E3EE3135-A79F-BC80-9779-8A80EFCCCC79}"/>
+              </a:ext>
+            </a:extLst>
+          </p:cNvPr>
+          <p:cNvSpPr>
+            <a:spLocks noGrp="1"/>
+          </p:cNvSpPr>
+          <p:nvPr>
+            <p:ph idx="1"/>
+          </p:nvPr>
+        </p:nvSpPr>
+        <p:spPr/>
+        <p:txBody>
+          <a:bodyPr/>
+          <a:lstStyle/>
+          <a:p>
             <a:pPr>
               <a:lnSpc>
                 <a:spcPct val="150000"/>
@@ -7702,6 +7831,118 @@
             </a:r>
           </a:p>
           <a:p>
+            <a:pPr lvl="1">
+              <a:lnSpc>
+                <a:spcPct val="150000"/>
+              </a:lnSpc>
+            </a:pPr>
+            <a:r>
+              <a:rPr lang="en-US" dirty="0">
+                <a:cs typeface="Courier New" panose="02070309020205020404" pitchFamily="49" charset="0"/>
+              </a:rPr>
+              <a:t>Same as alert, but also includes an input box for the user to type something in that will be saved in a variable or otherwise used in the code somehow</a:t>
+            </a:r>
+            <a:br>
+              <a:rPr lang="en-US" b="1" dirty="0">
+                <a:latin typeface="Courier New" panose="02070309020205020404" pitchFamily="49" charset="0"/>
+                <a:cs typeface="Courier New" panose="02070309020205020404" pitchFamily="49" charset="0"/>
+              </a:rPr>
+            </a:br>
+            <a:r>
+              <a:rPr lang="en-US" b="1" dirty="0">
+                <a:latin typeface="Courier New" panose="02070309020205020404" pitchFamily="49" charset="0"/>
+                <a:cs typeface="Courier New" panose="02070309020205020404" pitchFamily="49" charset="0"/>
+              </a:rPr>
+              <a:t>let age = prompt(“Please enter your age: “);</a:t>
+            </a:r>
+          </a:p>
+        </p:txBody>
+      </p:sp>
+    </p:spTree>
+    <p:extLst>
+      <p:ext uri="{BB962C8B-B14F-4D97-AF65-F5344CB8AC3E}">
+        <p14:creationId xmlns:p14="http://schemas.microsoft.com/office/powerpoint/2010/main" val="2674472734"/>
+      </p:ext>
+    </p:extLst>
+  </p:cSld>
+  <p:clrMapOvr>
+    <a:masterClrMapping/>
+  </p:clrMapOvr>
+</p:sld>
+</file>
+
+<file path=ppt/slides/slide24.xml><?xml version="1.0" encoding="utf-8"?>
+<p:sld xmlns:a="http://schemas.openxmlformats.org/drawingml/2006/main" xmlns:r="http://schemas.openxmlformats.org/officeDocument/2006/relationships" xmlns:p="http://schemas.openxmlformats.org/presentationml/2006/main">
+  <p:cSld>
+    <p:spTree>
+      <p:nvGrpSpPr>
+        <p:cNvPr id="1" name="">
+          <a:extLst>
+            <a:ext uri="{FF2B5EF4-FFF2-40B4-BE49-F238E27FC236}">
+              <a16:creationId xmlns:a16="http://schemas.microsoft.com/office/drawing/2014/main" id="{20A6B9AC-EC1A-53F3-E4CE-3039CDC9E0DA}"/>
+            </a:ext>
+          </a:extLst>
+        </p:cNvPr>
+        <p:cNvGrpSpPr/>
+        <p:nvPr/>
+      </p:nvGrpSpPr>
+      <p:grpSpPr>
+        <a:xfrm>
+          <a:off x="0" y="0"/>
+          <a:ext cx="0" cy="0"/>
+          <a:chOff x="0" y="0"/>
+          <a:chExt cx="0" cy="0"/>
+        </a:xfrm>
+      </p:grpSpPr>
+      <p:sp>
+        <p:nvSpPr>
+          <p:cNvPr id="2" name="Title 1">
+            <a:extLst>
+              <a:ext uri="{FF2B5EF4-FFF2-40B4-BE49-F238E27FC236}">
+                <a16:creationId xmlns:a16="http://schemas.microsoft.com/office/drawing/2014/main" id="{57365E91-1BCD-7AD0-D4CC-5B0159162F26}"/>
+              </a:ext>
+            </a:extLst>
+          </p:cNvPr>
+          <p:cNvSpPr>
+            <a:spLocks noGrp="1"/>
+          </p:cNvSpPr>
+          <p:nvPr>
+            <p:ph type="title"/>
+          </p:nvPr>
+        </p:nvSpPr>
+        <p:spPr/>
+        <p:txBody>
+          <a:bodyPr/>
+          <a:lstStyle/>
+          <a:p>
+            <a:r>
+              <a:rPr lang="en-US" dirty="0"/>
+              <a:t>Useful JavaScript Methods</a:t>
+            </a:r>
+          </a:p>
+        </p:txBody>
+      </p:sp>
+      <p:sp>
+        <p:nvSpPr>
+          <p:cNvPr id="3" name="Content Placeholder 2">
+            <a:extLst>
+              <a:ext uri="{FF2B5EF4-FFF2-40B4-BE49-F238E27FC236}">
+                <a16:creationId xmlns:a16="http://schemas.microsoft.com/office/drawing/2014/main" id="{2B88BB45-31CF-92BD-1001-3E609E3E5AED}"/>
+              </a:ext>
+            </a:extLst>
+          </p:cNvPr>
+          <p:cNvSpPr>
+            <a:spLocks noGrp="1"/>
+          </p:cNvSpPr>
+          <p:nvPr>
+            <p:ph idx="1"/>
+          </p:nvPr>
+        </p:nvSpPr>
+        <p:spPr/>
+        <p:txBody>
+          <a:bodyPr/>
+          <a:lstStyle/>
+          <a:p>
             <a:pPr>
               <a:lnSpc>
                 <a:spcPct val="150000"/>
@@ -7715,12 +7956,566 @@
               <a:t>console.log();</a:t>
             </a:r>
           </a:p>
+          <a:p>
+            <a:pPr lvl="1">
+              <a:lnSpc>
+                <a:spcPct val="150000"/>
+              </a:lnSpc>
+            </a:pPr>
+            <a:r>
+              <a:rPr lang="en-US" dirty="0">
+                <a:cs typeface="Courier New" panose="02070309020205020404" pitchFamily="49" charset="0"/>
+              </a:rPr>
+              <a:t>Prints into the browser’s console whatever is written within the method’s parentheses</a:t>
+            </a:r>
+          </a:p>
+          <a:p>
+            <a:pPr lvl="1">
+              <a:lnSpc>
+                <a:spcPct val="150000"/>
+              </a:lnSpc>
+            </a:pPr>
+            <a:r>
+              <a:rPr lang="en-US" dirty="0">
+                <a:cs typeface="Courier New" panose="02070309020205020404" pitchFamily="49" charset="0"/>
+              </a:rPr>
+              <a:t>Accessing the console</a:t>
+            </a:r>
+          </a:p>
+          <a:p>
+            <a:pPr lvl="2">
+              <a:lnSpc>
+                <a:spcPct val="150000"/>
+              </a:lnSpc>
+            </a:pPr>
+            <a:r>
+              <a:rPr lang="en-US" dirty="0">
+                <a:cs typeface="Courier New" panose="02070309020205020404" pitchFamily="49" charset="0"/>
+              </a:rPr>
+              <a:t>Hit </a:t>
+            </a:r>
+            <a:r>
+              <a:rPr lang="en-US" b="1" dirty="0">
+                <a:cs typeface="Courier New" panose="02070309020205020404" pitchFamily="49" charset="0"/>
+              </a:rPr>
+              <a:t>F12</a:t>
+            </a:r>
+            <a:r>
+              <a:rPr lang="en-US" dirty="0">
+                <a:cs typeface="Courier New" panose="02070309020205020404" pitchFamily="49" charset="0"/>
+              </a:rPr>
+              <a:t> key or right-click on web page and click “</a:t>
+            </a:r>
+            <a:r>
+              <a:rPr lang="en-US" b="1" dirty="0">
+                <a:cs typeface="Courier New" panose="02070309020205020404" pitchFamily="49" charset="0"/>
+              </a:rPr>
+              <a:t>Inspect</a:t>
+            </a:r>
+            <a:r>
+              <a:rPr lang="en-US" dirty="0">
+                <a:cs typeface="Courier New" panose="02070309020205020404" pitchFamily="49" charset="0"/>
+              </a:rPr>
+              <a:t>” to open Developer Tools</a:t>
+            </a:r>
+          </a:p>
+          <a:p>
+            <a:pPr lvl="2">
+              <a:lnSpc>
+                <a:spcPct val="150000"/>
+              </a:lnSpc>
+            </a:pPr>
+            <a:r>
+              <a:rPr lang="en-US" dirty="0">
+                <a:cs typeface="Courier New" panose="02070309020205020404" pitchFamily="49" charset="0"/>
+              </a:rPr>
+              <a:t>Click on </a:t>
+            </a:r>
+            <a:r>
+              <a:rPr lang="en-US" b="1" dirty="0">
+                <a:cs typeface="Courier New" panose="02070309020205020404" pitchFamily="49" charset="0"/>
+              </a:rPr>
+              <a:t>Console</a:t>
+            </a:r>
+            <a:r>
+              <a:rPr lang="en-US" dirty="0">
+                <a:cs typeface="Courier New" panose="02070309020205020404" pitchFamily="49" charset="0"/>
+              </a:rPr>
+              <a:t> at the top of Developer Tools</a:t>
+            </a:r>
+          </a:p>
         </p:txBody>
       </p:sp>
     </p:spTree>
     <p:extLst>
       <p:ext uri="{BB962C8B-B14F-4D97-AF65-F5344CB8AC3E}">
-        <p14:creationId xmlns:p14="http://schemas.microsoft.com/office/powerpoint/2010/main" val="1358443088"/>
+        <p14:creationId xmlns:p14="http://schemas.microsoft.com/office/powerpoint/2010/main" val="506366830"/>
+      </p:ext>
+    </p:extLst>
+  </p:cSld>
+  <p:clrMapOvr>
+    <a:masterClrMapping/>
+  </p:clrMapOvr>
+</p:sld>
+</file>
+
+<file path=ppt/slides/slide25.xml><?xml version="1.0" encoding="utf-8"?>
+<p:sld xmlns:a="http://schemas.openxmlformats.org/drawingml/2006/main" xmlns:r="http://schemas.openxmlformats.org/officeDocument/2006/relationships" xmlns:p="http://schemas.openxmlformats.org/presentationml/2006/main">
+  <p:cSld>
+    <p:spTree>
+      <p:nvGrpSpPr>
+        <p:cNvPr id="1" name=""/>
+        <p:cNvGrpSpPr/>
+        <p:nvPr/>
+      </p:nvGrpSpPr>
+      <p:grpSpPr>
+        <a:xfrm>
+          <a:off x="0" y="0"/>
+          <a:ext cx="0" cy="0"/>
+          <a:chOff x="0" y="0"/>
+          <a:chExt cx="0" cy="0"/>
+        </a:xfrm>
+      </p:grpSpPr>
+      <p:pic>
+        <p:nvPicPr>
+          <p:cNvPr id="3" name="Picture 2">
+            <a:extLst>
+              <a:ext uri="{FF2B5EF4-FFF2-40B4-BE49-F238E27FC236}">
+                <a16:creationId xmlns:a16="http://schemas.microsoft.com/office/drawing/2014/main" id="{F63A3F8E-2A0B-869C-377A-19212E02DF3B}"/>
+              </a:ext>
+            </a:extLst>
+          </p:cNvPr>
+          <p:cNvPicPr>
+            <a:picLocks noChangeAspect="1"/>
+          </p:cNvPicPr>
+          <p:nvPr/>
+        </p:nvPicPr>
+        <p:blipFill>
+          <a:blip r:embed="rId2"/>
+          <a:stretch>
+            <a:fillRect/>
+          </a:stretch>
+        </p:blipFill>
+        <p:spPr>
+          <a:xfrm>
+            <a:off x="823374" y="0"/>
+            <a:ext cx="10545252" cy="6858000"/>
+          </a:xfrm>
+          <a:prstGeom prst="rect">
+            <a:avLst/>
+          </a:prstGeom>
+        </p:spPr>
+      </p:pic>
+    </p:spTree>
+    <p:extLst>
+      <p:ext uri="{BB962C8B-B14F-4D97-AF65-F5344CB8AC3E}">
+        <p14:creationId xmlns:p14="http://schemas.microsoft.com/office/powerpoint/2010/main" val="602207211"/>
+      </p:ext>
+    </p:extLst>
+  </p:cSld>
+  <p:clrMapOvr>
+    <a:masterClrMapping/>
+  </p:clrMapOvr>
+</p:sld>
+</file>
+
+<file path=ppt/slides/slide26.xml><?xml version="1.0" encoding="utf-8"?>
+<p:sld xmlns:a="http://schemas.openxmlformats.org/drawingml/2006/main" xmlns:r="http://schemas.openxmlformats.org/officeDocument/2006/relationships" xmlns:p="http://schemas.openxmlformats.org/presentationml/2006/main">
+  <p:cSld>
+    <p:spTree>
+      <p:nvGrpSpPr>
+        <p:cNvPr id="1" name=""/>
+        <p:cNvGrpSpPr/>
+        <p:nvPr/>
+      </p:nvGrpSpPr>
+      <p:grpSpPr>
+        <a:xfrm>
+          <a:off x="0" y="0"/>
+          <a:ext cx="0" cy="0"/>
+          <a:chOff x="0" y="0"/>
+          <a:chExt cx="0" cy="0"/>
+        </a:xfrm>
+      </p:grpSpPr>
+      <p:pic>
+        <p:nvPicPr>
+          <p:cNvPr id="3" name="Picture 2">
+            <a:extLst>
+              <a:ext uri="{FF2B5EF4-FFF2-40B4-BE49-F238E27FC236}">
+                <a16:creationId xmlns:a16="http://schemas.microsoft.com/office/drawing/2014/main" id="{FBEC5125-677E-8FEF-18D8-73EFE5DB9371}"/>
+              </a:ext>
+            </a:extLst>
+          </p:cNvPr>
+          <p:cNvPicPr>
+            <a:picLocks noChangeAspect="1"/>
+          </p:cNvPicPr>
+          <p:nvPr/>
+        </p:nvPicPr>
+        <p:blipFill>
+          <a:blip r:embed="rId2"/>
+          <a:stretch>
+            <a:fillRect/>
+          </a:stretch>
+        </p:blipFill>
+        <p:spPr>
+          <a:xfrm>
+            <a:off x="2796144" y="0"/>
+            <a:ext cx="6599712" cy="6858000"/>
+          </a:xfrm>
+          <a:prstGeom prst="rect">
+            <a:avLst/>
+          </a:prstGeom>
+        </p:spPr>
+      </p:pic>
+    </p:spTree>
+    <p:extLst>
+      <p:ext uri="{BB962C8B-B14F-4D97-AF65-F5344CB8AC3E}">
+        <p14:creationId xmlns:p14="http://schemas.microsoft.com/office/powerpoint/2010/main" val="1774782266"/>
+      </p:ext>
+    </p:extLst>
+  </p:cSld>
+  <p:clrMapOvr>
+    <a:masterClrMapping/>
+  </p:clrMapOvr>
+</p:sld>
+</file>
+
+<file path=ppt/slides/slide27.xml><?xml version="1.0" encoding="utf-8"?>
+<p:sld xmlns:a="http://schemas.openxmlformats.org/drawingml/2006/main" xmlns:r="http://schemas.openxmlformats.org/officeDocument/2006/relationships" xmlns:p="http://schemas.openxmlformats.org/presentationml/2006/main">
+  <p:cSld>
+    <p:spTree>
+      <p:nvGrpSpPr>
+        <p:cNvPr id="1" name=""/>
+        <p:cNvGrpSpPr/>
+        <p:nvPr/>
+      </p:nvGrpSpPr>
+      <p:grpSpPr>
+        <a:xfrm>
+          <a:off x="0" y="0"/>
+          <a:ext cx="0" cy="0"/>
+          <a:chOff x="0" y="0"/>
+          <a:chExt cx="0" cy="0"/>
+        </a:xfrm>
+      </p:grpSpPr>
+      <p:sp>
+        <p:nvSpPr>
+          <p:cNvPr id="2" name="Title 1">
+            <a:extLst>
+              <a:ext uri="{FF2B5EF4-FFF2-40B4-BE49-F238E27FC236}">
+                <a16:creationId xmlns:a16="http://schemas.microsoft.com/office/drawing/2014/main" id="{73655FEE-8809-F6C2-5506-F9C6597FCD4B}"/>
+              </a:ext>
+            </a:extLst>
+          </p:cNvPr>
+          <p:cNvSpPr>
+            <a:spLocks noGrp="1"/>
+          </p:cNvSpPr>
+          <p:nvPr>
+            <p:ph type="title"/>
+          </p:nvPr>
+        </p:nvSpPr>
+        <p:spPr/>
+        <p:txBody>
+          <a:bodyPr/>
+          <a:lstStyle/>
+          <a:p>
+            <a:r>
+              <a:rPr lang="en-US" dirty="0"/>
+              <a:t>References</a:t>
+            </a:r>
+          </a:p>
+        </p:txBody>
+      </p:sp>
+      <p:sp>
+        <p:nvSpPr>
+          <p:cNvPr id="3" name="Content Placeholder 2">
+            <a:extLst>
+              <a:ext uri="{FF2B5EF4-FFF2-40B4-BE49-F238E27FC236}">
+                <a16:creationId xmlns:a16="http://schemas.microsoft.com/office/drawing/2014/main" id="{AA8F3339-7D3E-E5C2-DEF2-FB12E7D9CAB8}"/>
+              </a:ext>
+            </a:extLst>
+          </p:cNvPr>
+          <p:cNvSpPr>
+            <a:spLocks noGrp="1"/>
+          </p:cNvSpPr>
+          <p:nvPr>
+            <p:ph idx="1"/>
+          </p:nvPr>
+        </p:nvSpPr>
+        <p:spPr/>
+        <p:txBody>
+          <a:bodyPr>
+            <a:normAutofit/>
+          </a:bodyPr>
+          <a:lstStyle/>
+          <a:p>
+            <a:pPr marL="457200" indent="-457200">
+              <a:spcAft>
+                <a:spcPts val="1200"/>
+              </a:spcAft>
+              <a:buFont typeface="+mj-lt"/>
+              <a:buAutoNum type="arabicPeriod"/>
+            </a:pPr>
+            <a:r>
+              <a:rPr lang="en-US" u="sng" dirty="0"/>
+              <a:t>What is JavaScript</a:t>
+            </a:r>
+            <a:r>
+              <a:rPr lang="en-US" dirty="0"/>
+              <a:t>?, MDN Web Docs, </a:t>
+            </a:r>
+            <a:r>
+              <a:rPr lang="en-US" dirty="0">
+                <a:hlinkClick r:id="rId2"/>
+              </a:rPr>
+              <a:t>https://developer.mozilla.org/en-US/docs/Learn/JavaScript/First_Steps/What_is_JavaScript</a:t>
+            </a:r>
+            <a:r>
+              <a:rPr lang="en-US" dirty="0"/>
+              <a:t>, accessed May 19, 2024.</a:t>
+            </a:r>
+          </a:p>
+          <a:p>
+            <a:pPr marL="457200" indent="-457200">
+              <a:spcAft>
+                <a:spcPts val="1200"/>
+              </a:spcAft>
+              <a:buFont typeface="+mj-lt"/>
+              <a:buAutoNum type="arabicPeriod"/>
+            </a:pPr>
+            <a:r>
+              <a:rPr lang="en-US" u="sng" dirty="0"/>
+              <a:t>Why JavaScript is called lightweight?</a:t>
+            </a:r>
+            <a:r>
+              <a:rPr lang="en-US" dirty="0"/>
+              <a:t>, Subodh Kumar, JavaScript in Plain English, Jan 3, 2022, </a:t>
+            </a:r>
+            <a:r>
+              <a:rPr lang="en-US" dirty="0">
+                <a:hlinkClick r:id="rId3"/>
+              </a:rPr>
+              <a:t>https://javascript.plainenglish.io/why-javascript-is-called-lightweight-5a1996db9ef6</a:t>
+            </a:r>
+            <a:r>
+              <a:rPr lang="en-US" dirty="0"/>
+              <a:t>, accessed May 19, 2024.</a:t>
+            </a:r>
+          </a:p>
+          <a:p>
+            <a:pPr marL="457200" indent="-457200">
+              <a:spcAft>
+                <a:spcPts val="1200"/>
+              </a:spcAft>
+              <a:buFont typeface="+mj-lt"/>
+              <a:buAutoNum type="arabicPeriod"/>
+            </a:pPr>
+            <a:r>
+              <a:rPr lang="en-US" u="sng" dirty="0"/>
+              <a:t>Introduction to JavaScript</a:t>
+            </a:r>
+            <a:r>
+              <a:rPr lang="en-US" dirty="0"/>
+              <a:t>, </a:t>
+            </a:r>
+            <a:r>
+              <a:rPr lang="en-US" dirty="0" err="1"/>
+              <a:t>GeeksForGeeks</a:t>
+            </a:r>
+            <a:r>
+              <a:rPr lang="en-US" dirty="0"/>
+              <a:t>, last updated Feb 2, 2024, </a:t>
+            </a:r>
+            <a:r>
+              <a:rPr lang="en-US" dirty="0">
+                <a:hlinkClick r:id="rId4"/>
+              </a:rPr>
+              <a:t>https://www.geeksforgeeks.org/introduction-to-javascript/</a:t>
+            </a:r>
+            <a:r>
+              <a:rPr lang="en-US" dirty="0"/>
+              <a:t>, accessed May 19, 2024.</a:t>
+            </a:r>
+          </a:p>
+        </p:txBody>
+      </p:sp>
+    </p:spTree>
+    <p:extLst>
+      <p:ext uri="{BB962C8B-B14F-4D97-AF65-F5344CB8AC3E}">
+        <p14:creationId xmlns:p14="http://schemas.microsoft.com/office/powerpoint/2010/main" val="2505309451"/>
+      </p:ext>
+    </p:extLst>
+  </p:cSld>
+  <p:clrMapOvr>
+    <a:masterClrMapping/>
+  </p:clrMapOvr>
+</p:sld>
+</file>
+
+<file path=ppt/slides/slide28.xml><?xml version="1.0" encoding="utf-8"?>
+<p:sld xmlns:a="http://schemas.openxmlformats.org/drawingml/2006/main" xmlns:r="http://schemas.openxmlformats.org/officeDocument/2006/relationships" xmlns:p="http://schemas.openxmlformats.org/presentationml/2006/main">
+  <p:cSld>
+    <p:spTree>
+      <p:nvGrpSpPr>
+        <p:cNvPr id="1" name=""/>
+        <p:cNvGrpSpPr/>
+        <p:nvPr/>
+      </p:nvGrpSpPr>
+      <p:grpSpPr>
+        <a:xfrm>
+          <a:off x="0" y="0"/>
+          <a:ext cx="0" cy="0"/>
+          <a:chOff x="0" y="0"/>
+          <a:chExt cx="0" cy="0"/>
+        </a:xfrm>
+      </p:grpSpPr>
+      <p:sp>
+        <p:nvSpPr>
+          <p:cNvPr id="2" name="Title 1">
+            <a:extLst>
+              <a:ext uri="{FF2B5EF4-FFF2-40B4-BE49-F238E27FC236}">
+                <a16:creationId xmlns:a16="http://schemas.microsoft.com/office/drawing/2014/main" id="{DBD81078-975B-691B-F029-DFC3751102AF}"/>
+              </a:ext>
+            </a:extLst>
+          </p:cNvPr>
+          <p:cNvSpPr>
+            <a:spLocks noGrp="1"/>
+          </p:cNvSpPr>
+          <p:nvPr>
+            <p:ph type="title"/>
+          </p:nvPr>
+        </p:nvSpPr>
+        <p:spPr/>
+        <p:txBody>
+          <a:bodyPr/>
+          <a:lstStyle/>
+          <a:p>
+            <a:r>
+              <a:rPr lang="en-US" dirty="0"/>
+              <a:t>References (cont’d)</a:t>
+            </a:r>
+          </a:p>
+        </p:txBody>
+      </p:sp>
+      <p:sp>
+        <p:nvSpPr>
+          <p:cNvPr id="3" name="Content Placeholder 2">
+            <a:extLst>
+              <a:ext uri="{FF2B5EF4-FFF2-40B4-BE49-F238E27FC236}">
+                <a16:creationId xmlns:a16="http://schemas.microsoft.com/office/drawing/2014/main" id="{AAB18BE0-4107-4276-0ADA-D8F30FECD075}"/>
+              </a:ext>
+            </a:extLst>
+          </p:cNvPr>
+          <p:cNvSpPr>
+            <a:spLocks noGrp="1"/>
+          </p:cNvSpPr>
+          <p:nvPr>
+            <p:ph idx="1"/>
+          </p:nvPr>
+        </p:nvSpPr>
+        <p:spPr/>
+        <p:txBody>
+          <a:bodyPr/>
+          <a:lstStyle/>
+          <a:p>
+            <a:pPr marL="457200" indent="-457200">
+              <a:spcAft>
+                <a:spcPts val="1200"/>
+              </a:spcAft>
+              <a:buFont typeface="+mj-lt"/>
+              <a:buAutoNum type="arabicPeriod" startAt="4"/>
+            </a:pPr>
+            <a:r>
+              <a:rPr lang="en-US" u="sng" dirty="0"/>
+              <a:t>Interpreted vs Compiled Programming Languages: What’s the Difference?</a:t>
+            </a:r>
+            <a:r>
+              <a:rPr lang="en-US" dirty="0"/>
+              <a:t>, Free Code Camp, January 10, 2020, </a:t>
+            </a:r>
+            <a:r>
+              <a:rPr lang="en-US" dirty="0">
+                <a:hlinkClick r:id="rId2"/>
+              </a:rPr>
+              <a:t>https://www.freecodecamp.org/news/compiled-versus-interpreted-languages/</a:t>
+            </a:r>
+            <a:r>
+              <a:rPr lang="en-US" dirty="0"/>
+              <a:t>, accessed May 19, 2024.</a:t>
+            </a:r>
+          </a:p>
+          <a:p>
+            <a:pPr marL="457200" indent="-457200">
+              <a:spcAft>
+                <a:spcPts val="1200"/>
+              </a:spcAft>
+              <a:buFont typeface="+mj-lt"/>
+              <a:buAutoNum type="arabicPeriod" startAt="4"/>
+            </a:pPr>
+            <a:r>
+              <a:rPr lang="en-US" u="sng" dirty="0"/>
+              <a:t>Why is JavaScript Single Threaded?</a:t>
+            </a:r>
+            <a:r>
+              <a:rPr lang="en-US" dirty="0"/>
+              <a:t>, Matt Long, Grove Technology, July 21, 2023, </a:t>
+            </a:r>
+            <a:r>
+              <a:rPr lang="en" u="sng" dirty="0">
+                <a:solidFill>
+                  <a:schemeClr val="hlink"/>
+                </a:solidFill>
+                <a:hlinkClick r:id="rId3"/>
+              </a:rPr>
+              <a:t>https://groovetechnology.com/blog/why-javascript-is-single-threaded/#:~:text=JavaScript%20was%20designed%20to%20be,interactivity%20to%20static%20web%20pages</a:t>
+            </a:r>
+            <a:r>
+              <a:rPr lang="en-US" u="sng" dirty="0">
+                <a:solidFill>
+                  <a:schemeClr val="hlink"/>
+                </a:solidFill>
+              </a:rPr>
+              <a:t>,</a:t>
+            </a:r>
+            <a:r>
+              <a:rPr lang="en-US" dirty="0"/>
+              <a:t> accessed May 19, 2024.</a:t>
+            </a:r>
+          </a:p>
+          <a:p>
+            <a:pPr marL="457200" indent="-457200">
+              <a:spcAft>
+                <a:spcPts val="1200"/>
+              </a:spcAft>
+              <a:buFont typeface="+mj-lt"/>
+              <a:buAutoNum type="arabicPeriod" startAt="4"/>
+            </a:pPr>
+            <a:r>
+              <a:rPr lang="en-US" dirty="0"/>
+              <a:t>Just in Time Compilation Explained, Free Code Camp, Feb 1, 2020, </a:t>
+            </a:r>
+            <a:r>
+              <a:rPr lang="en-US" dirty="0">
+                <a:hlinkClick r:id="rId4"/>
+              </a:rPr>
+              <a:t>https://www.freecodecamp.org/news/just-in-time-compilation-explained</a:t>
+            </a:r>
+            <a:r>
+              <a:rPr lang="en-US">
+                <a:hlinkClick r:id="rId4"/>
+              </a:rPr>
+              <a:t>/</a:t>
+            </a:r>
+            <a:r>
+              <a:rPr lang="en-US"/>
+              <a:t>, accessed May 19, 2024.</a:t>
+            </a:r>
+            <a:endParaRPr lang="en-US" dirty="0"/>
+          </a:p>
+        </p:txBody>
+      </p:sp>
+    </p:spTree>
+    <p:extLst>
+      <p:ext uri="{BB962C8B-B14F-4D97-AF65-F5344CB8AC3E}">
+        <p14:creationId xmlns:p14="http://schemas.microsoft.com/office/powerpoint/2010/main" val="3452872806"/>
       </p:ext>
     </p:extLst>
   </p:cSld>

</xml_diff>